<commit_message>
docs: update team branding to Team IRON
</commit_message>
<xml_diff>
--- a/docs/AI_Defense_Lab_Presentation.pptx
+++ b/docs/AI_Defense_Lab_Presentation.pptx
@@ -3545,7 +3545,7 @@
               </a:defRPr>
             </a:pPr>
             <a:r>
-              <a:t>Team: AITIANS  |  Army Institute of Technology, Pune</a:t>
+              <a:t>Team: IRON  |  AI Defense Lab</a:t>
             </a:r>
           </a:p>
         </p:txBody>
@@ -5051,7 +5051,7 @@
               </a:defRPr>
             </a:pPr>
             <a:r>
-              <a:t>Team AITIANS — Final Takeaway</a:t>
+              <a:t>Team IRON — Final Takeaway</a:t>
             </a:r>
           </a:p>
           <a:p>
@@ -5147,7 +5147,7 @@
               </a:defRPr>
             </a:pPr>
             <a:r>
-              <a:t>Team: AITIANS (Army Institute of Technology, Pune)</a:t>
+              <a:t>Team: IRON</a:t>
             </a:r>
           </a:p>
           <a:p>

</xml_diff>

<commit_message>
docs: add Mastercard AI Defense Lab live Vercel and GitHub links to presentation
</commit_message>
<xml_diff>
--- a/docs/AI_Defense_Lab_Presentation.pptx
+++ b/docs/AI_Defense_Lab_Presentation.pptx
@@ -3540,12 +3540,12 @@
             <a:pPr>
               <a:defRPr sz="1200">
                 <a:solidFill>
-                  <a:srgbClr val="94A3B8"/>
-                </a:solidFill>
-              </a:defRPr>
-            </a:pPr>
-            <a:r>
-              <a:t>Team: IRON  |  AI Defense Lab</a:t>
+                  <a:srgbClr val="F59E0B"/>
+                </a:solidFill>
+              </a:defRPr>
+            </a:pPr>
+            <a:r>
+              <a:t>Team: IRON  |  Live Prototype: https://defense-six.vercel.app/  |  GitHub: https://github.com/Abhay-s-8/defense</a:t>
             </a:r>
           </a:p>
         </p:txBody>
@@ -5142,27 +5142,42 @@
               </a:spcBef>
               <a:defRPr sz="1200">
                 <a:solidFill>
-                  <a:srgbClr val="94A3B8"/>
-                </a:solidFill>
-              </a:defRPr>
-            </a:pPr>
-            <a:r>
-              <a:t>Team: IRON</a:t>
-            </a:r>
-          </a:p>
-          <a:p>
-            <a:pPr algn="l">
-              <a:spcBef>
-                <a:spcPts val="500"/>
-              </a:spcBef>
-              <a:defRPr sz="1200">
-                <a:solidFill>
-                  <a:srgbClr val="94A3B8"/>
-                </a:solidFill>
-              </a:defRPr>
-            </a:pPr>
-            <a:r>
-              <a:t>GitHub: github.com/Abhay-s-8/defense</a:t>
+                  <a:srgbClr val="FFFFFF"/>
+                </a:solidFill>
+              </a:defRPr>
+            </a:pPr>
+            <a:r>
+              <a:t>★ Team: IRON</a:t>
+            </a:r>
+          </a:p>
+          <a:p>
+            <a:pPr algn="l">
+              <a:spcBef>
+                <a:spcPts val="500"/>
+              </a:spcBef>
+              <a:defRPr sz="1200">
+                <a:solidFill>
+                  <a:srgbClr val="FFFFFF"/>
+                </a:solidFill>
+              </a:defRPr>
+            </a:pPr>
+            <a:r>
+              <a:t>★ Live Prototype: https://defense-six.vercel.app/</a:t>
+            </a:r>
+          </a:p>
+          <a:p>
+            <a:pPr algn="l">
+              <a:spcBef>
+                <a:spcPts val="500"/>
+              </a:spcBef>
+              <a:defRPr sz="1200">
+                <a:solidFill>
+                  <a:srgbClr val="FFFFFF"/>
+                </a:solidFill>
+              </a:defRPr>
+            </a:pPr>
+            <a:r>
+              <a:t>★ GitHub Repo: https://github.com/Abhay-s-8/defense</a:t>
             </a:r>
           </a:p>
         </p:txBody>

</xml_diff>